<commit_message>
docs: redesigned committee deck (v2, desaturated brand palette) with named sanction precedents
Adds the v2 deck and its build script, the single-slide synthesis
infographic, and updates the risk slide and annex with the CMF
resolutions (Res. Ex. 5.664 and 5.666, jul. 2024; Res. 1.183, ene. 2026).

Co-Authored-By: Claude Fable 5.1 <noreply@anthropic.com>
Claude-Session: https://claude.ai/code/session_01EdiFW99rh4cyUjRbojqkjk
</commit_message>
<xml_diff>
--- a/docs/benchmarking/presentacion-reportes-normativos-v2.pptx
+++ b/docs/benchmarking/presentacion-reportes-normativos-v2.pptx
@@ -10841,7 +10841,7 @@
                 <a:ea typeface="Calibri" pitchFamily="34" charset="-122"/>
                 <a:cs typeface="Calibri" pitchFamily="34" charset="-120"/>
               </a:rPr>
-              <a:t>Identificación de archivos y precedentes: comunicados de la CMF sobre multas por el Estado de Deudores (julio 2024) y por el archivo R13 (enero 2026); Ley 21.680 y NCG N° 540 del Registro de Deuda Consolidada; Manual del Sistema de Información (Sistema de Productos y de Deudores); Circular N° 2.376; Circular Interpretativa del SERNAC sobre portabilidad.</a:t>
+              <a:t>Precedentes: CMF, 4 de julio de 2024, Resoluciones Exentas N° 5.664 (Banco Santander Chile, UF 2.500) y N° 5.666 (Coopeuch, UF 1.000) por el Estado de Deudores, RAN 18-5 y art. 14 LGB; CMF, 30 de enero de 2026, Resolución N° 1.183 (Banco Santander-Chile, UF 2.500) por el archivo R13, RAN 21-13. Identificación de archivos: Ley 21.680 y NCG N° 540 del Registro de Deuda Consolidada; Manual del Sistema de Información (Sistema de Productos y de Deudores); Circular N° 2.376; Circular Interpretativa del SERNAC sobre portabilidad.</a:t>
             </a:r>
             <a:endParaRPr lang="en-US" sz="1150" dirty="0"/>
           </a:p>
@@ -16344,12 +16344,12 @@
         </p:nvSpPr>
         <p:spPr>
           <a:xfrm>
-            <a:off x="548640" y="1965960"/>
-            <a:ext cx="5440680" cy="1828800"/>
+            <a:off x="548640" y="1920240"/>
+            <a:ext cx="5440680" cy="1965960"/>
           </a:xfrm>
           <a:prstGeom prst="roundRect">
             <a:avLst>
-              <a:gd name="adj" fmla="val 3000"/>
+              <a:gd name="adj" fmla="val 2791"/>
             </a:avLst>
           </a:prstGeom>
           <a:solidFill>
@@ -16371,7 +16371,7 @@
         </p:nvSpPr>
         <p:spPr>
           <a:xfrm>
-            <a:off x="777240" y="2130552"/>
+            <a:off x="777240" y="2084832"/>
             <a:ext cx="4983480" cy="365760"/>
           </a:xfrm>
           <a:prstGeom prst="rect">
@@ -16410,8 +16410,8 @@
         </p:nvSpPr>
         <p:spPr>
           <a:xfrm>
-            <a:off x="777240" y="2514600"/>
-            <a:ext cx="4983480" cy="1143000"/>
+            <a:off x="777240" y="2468880"/>
+            <a:ext cx="4983480" cy="1280160"/>
           </a:xfrm>
           <a:prstGeom prst="rect">
             <a:avLst/>
@@ -16427,7 +16427,7 @@
               <a:buNone/>
             </a:pPr>
             <a:r>
-              <a:rPr lang="en-US" sz="1100" dirty="0">
+              <a:rPr lang="en-US" sz="1050" dirty="0">
                 <a:solidFill>
                   <a:srgbClr val="2B2F36"/>
                 </a:solidFill>
@@ -16437,7 +16437,7 @@
               </a:rPr>
               <a:t>Un incumplimiento en RDC01, RDC02 o RDC40 puede derivar en la suspensión del acceso al Registro de Deuda Consolidada hasta por un año (Ley 21.680). Sin esa información, el banco no puede evaluar deuda consolidada al originar créditos.</a:t>
             </a:r>
-            <a:endParaRPr lang="en-US" sz="1100" dirty="0"/>
+            <a:endParaRPr lang="en-US" sz="1050" dirty="0"/>
           </a:p>
         </p:txBody>
       </p:sp>
@@ -16449,12 +16449,12 @@
         </p:nvSpPr>
         <p:spPr>
           <a:xfrm>
-            <a:off x="6172200" y="1965960"/>
-            <a:ext cx="5440680" cy="1828800"/>
+            <a:off x="6172200" y="1920240"/>
+            <a:ext cx="5440680" cy="1965960"/>
           </a:xfrm>
           <a:prstGeom prst="roundRect">
             <a:avLst>
-              <a:gd name="adj" fmla="val 3000"/>
+              <a:gd name="adj" fmla="val 2791"/>
             </a:avLst>
           </a:prstGeom>
           <a:solidFill>
@@ -16476,7 +16476,7 @@
         </p:nvSpPr>
         <p:spPr>
           <a:xfrm>
-            <a:off x="6400800" y="2130552"/>
+            <a:off x="6400800" y="2084832"/>
             <a:ext cx="4983480" cy="365760"/>
           </a:xfrm>
           <a:prstGeom prst="rect">
@@ -16515,8 +16515,8 @@
         </p:nvSpPr>
         <p:spPr>
           <a:xfrm>
-            <a:off x="6400800" y="2514600"/>
-            <a:ext cx="4983480" cy="1143000"/>
+            <a:off x="6400800" y="2468880"/>
+            <a:ext cx="4983480" cy="1280160"/>
           </a:xfrm>
           <a:prstGeom prst="rect">
             <a:avLst/>
@@ -16532,7 +16532,7 @@
               <a:buNone/>
             </a:pPr>
             <a:r>
-              <a:rPr lang="en-US" sz="1100" dirty="0">
+              <a:rPr lang="en-US" sz="1050" dirty="0">
                 <a:solidFill>
                   <a:srgbClr val="2B2F36"/>
                 </a:solidFill>
@@ -16540,9 +16540,9 @@
                 <a:ea typeface="Calibri" pitchFamily="34" charset="-122"/>
                 <a:cs typeface="Calibri" pitchFamily="34" charset="-120"/>
               </a:rPr>
-              <a:t>Julio de 2024: UF 2.500 a un banco y UF 1.000 a una cooperativa por incluir en el Estado de Deudores (D10) a personas que no cumplían las condiciones. Enero de 2026: UF 2.500 por información inexacta en un archivo del Sistema de Riesgo, citando debilidades de control.</a:t>
-            </a:r>
-            <a:endParaRPr lang="en-US" sz="1100" dirty="0"/>
+              <a:t>Julio de 2024: Banco Santander Chile, UF 2.500 (Res. Ex. N° 5.664) y Coopeuch, UF 1.000 (Res. Ex. N° 5.666), por incluir en el Estado de Deudores (D10) a personas que no cumplían las condiciones; RAN 18-5 y art. 14 LGB. Enero de 2026: Banco Santander-Chile, UF 2.500 (Res. N° 1.183), por informar en el archivo R13 una sensibilidad Delta EVE inferior a la exigida entre abril de 2023 y enero de 2025; la CMF citó debilidades de control (RAN 21-13).</a:t>
+            </a:r>
+            <a:endParaRPr lang="en-US" sz="1050" dirty="0"/>
           </a:p>
         </p:txBody>
       </p:sp>
@@ -16554,12 +16554,12 @@
         </p:nvSpPr>
         <p:spPr>
           <a:xfrm>
-            <a:off x="548640" y="3977640"/>
-            <a:ext cx="5440680" cy="1828800"/>
+            <a:off x="548640" y="4023360"/>
+            <a:ext cx="5440680" cy="1965960"/>
           </a:xfrm>
           <a:prstGeom prst="roundRect">
             <a:avLst>
-              <a:gd name="adj" fmla="val 3000"/>
+              <a:gd name="adj" fmla="val 2791"/>
             </a:avLst>
           </a:prstGeom>
           <a:solidFill>
@@ -16581,7 +16581,7 @@
         </p:nvSpPr>
         <p:spPr>
           <a:xfrm>
-            <a:off x="777240" y="4142232"/>
+            <a:off x="777240" y="4187952"/>
             <a:ext cx="4983480" cy="365760"/>
           </a:xfrm>
           <a:prstGeom prst="rect">
@@ -16620,8 +16620,8 @@
         </p:nvSpPr>
         <p:spPr>
           <a:xfrm>
-            <a:off x="777240" y="4526280"/>
-            <a:ext cx="4983480" cy="1143000"/>
+            <a:off x="777240" y="4572000"/>
+            <a:ext cx="4983480" cy="1280160"/>
           </a:xfrm>
           <a:prstGeom prst="rect">
             <a:avLst/>
@@ -16637,7 +16637,7 @@
               <a:buNone/>
             </a:pPr>
             <a:r>
-              <a:rPr lang="en-US" sz="1100" dirty="0">
+              <a:rPr lang="en-US" sz="1050" dirty="0">
                 <a:solidFill>
                   <a:srgbClr val="2B2F36"/>
                 </a:solidFill>
@@ -16647,7 +16647,7 @@
               </a:rPr>
               <a:t>Un error en información de deudores o en el reporte al SERNAC afecta a clientes concretos y a la relación con el regulador, con visibilidad pública.</a:t>
             </a:r>
-            <a:endParaRPr lang="en-US" sz="1100" dirty="0"/>
+            <a:endParaRPr lang="en-US" sz="1050" dirty="0"/>
           </a:p>
         </p:txBody>
       </p:sp>
@@ -16659,12 +16659,12 @@
         </p:nvSpPr>
         <p:spPr>
           <a:xfrm>
-            <a:off x="6172200" y="3977640"/>
-            <a:ext cx="5440680" cy="1828800"/>
+            <a:off x="6172200" y="4023360"/>
+            <a:ext cx="5440680" cy="1965960"/>
           </a:xfrm>
           <a:prstGeom prst="roundRect">
             <a:avLst>
-              <a:gd name="adj" fmla="val 3000"/>
+              <a:gd name="adj" fmla="val 2791"/>
             </a:avLst>
           </a:prstGeom>
           <a:solidFill>
@@ -16686,7 +16686,7 @@
         </p:nvSpPr>
         <p:spPr>
           <a:xfrm>
-            <a:off x="6400800" y="4142232"/>
+            <a:off x="6400800" y="4187952"/>
             <a:ext cx="4983480" cy="365760"/>
           </a:xfrm>
           <a:prstGeom prst="rect">
@@ -16725,8 +16725,8 @@
         </p:nvSpPr>
         <p:spPr>
           <a:xfrm>
-            <a:off x="6400800" y="4526280"/>
-            <a:ext cx="4983480" cy="1143000"/>
+            <a:off x="6400800" y="4572000"/>
+            <a:ext cx="4983480" cy="1280160"/>
           </a:xfrm>
           <a:prstGeom prst="rect">
             <a:avLst/>
@@ -16742,7 +16742,7 @@
               <a:buNone/>
             </a:pPr>
             <a:r>
-              <a:rPr lang="en-US" sz="1100" dirty="0">
+              <a:rPr lang="en-US" sz="1050" dirty="0">
                 <a:solidFill>
                   <a:srgbClr val="2B2F36"/>
                 </a:solidFill>
@@ -16752,7 +16752,7 @@
               </a:rPr>
               <a:t>Seis personas sostienen 18 reportes con envíos diarios y semanales. La pérdida de una persona clave no se reemplaza en semanas: el conocimiento normativo y técnico es escaso.</a:t>
             </a:r>
-            <a:endParaRPr lang="en-US" sz="1100" dirty="0"/>
+            <a:endParaRPr lang="en-US" sz="1050" dirty="0"/>
           </a:p>
         </p:txBody>
       </p:sp>
@@ -16789,7 +16789,7 @@
                 <a:ea typeface="Calibri" pitchFamily="34" charset="-122"/>
                 <a:cs typeface="Calibri" pitchFamily="34" charset="-120"/>
               </a:rPr>
-              <a:t>Fuentes: CMF, multas por deficiencias en el Estado de Deudores (jul. 2024) y por información inexacta en el archivo R13 (ene. 2026); Ley 21.680. Enlaces en el anexo 3.</a:t>
+              <a:t>Fuentes: comunicados de la CMF del 4 de julio de 2024 (Estado de Deudores) y del 30 de enero de 2026 (archivo R13); Ley 21.680 y NCG N° 540. Enlaces en el anexo 3.</a:t>
             </a:r>
             <a:endParaRPr lang="en-US" sz="800" dirty="0"/>
           </a:p>

</xml_diff>